<commit_message>
Unify every mail address on noreply.ai@satisgroup.co.uk; de-dash the decks
Every mailto link, displayed address, throttle message, send-failure
message, JSON-LD contact, security.txt and llms.txt entry now points at
noreply.ai@satisgroup.co.uk, and the Resend delivery default follows suit,
so form submissions and email-link traffic land in one inbox. The insight
pull-quote parser now accepts "-- " as well as the long dash for
attributions, matching the report task parser, so the syntax can be typed
without special characters.

The webinar decks are rebuilt without a single em-dash on any slide or in
any speaker note: labels use middots, step titles use colons, prose uses
commas and full stops, and the task/pull-quote syntax is taught in its
double-dash form. Deck copy now names the unified enquiries inbox
throughout.

Co-Authored-By: Claude <noreply@anthropic.com>
Claude-Session: https://claude.ai/code/session_015acH6fUUCAPGjYzJxYs8yK
</commit_message>
<xml_diff>
--- a/docs/webinars/01-editing-the-website-with-claude.pptx
+++ b/docs/webinars/01-editing-the-website-with-claude.pptx
@@ -689,7 +689,7 @@
           <a:p>
             <a:r>
               <a:rPr lang="en-US" dirty="0"/>
-              <a:t>Close the loop on fear. The three safety properties: visibility before commit, audit trail after, rollback always. Invite the room to try one small real request this week — a typo fix or a status change.</a:t>
+              <a:t>Close the loop on fear. The three safety properties: visibility before commit, audit trail after, rollback always. Invite the room to try one small real request this week, like a typo fix or a status change.</a:t>
             </a:r>
             <a:endParaRPr lang="en-US" dirty="0"/>
           </a:p>
@@ -865,7 +865,7 @@
           <a:p>
             <a:r>
               <a:rPr lang="en-US" dirty="0"/>
-              <a:t>Run through the agenda quickly. Emphasise the promise: by the end of the session everyone here can change the website themselves — safely.</a:t>
+              <a:t>Run through the agenda quickly. Emphasise the promise: by the end of the session everyone here can change the website themselves, safely.</a:t>
             </a:r>
             <a:endParaRPr lang="en-US" dirty="0"/>
           </a:p>
@@ -953,7 +953,7 @@
           <a:p>
             <a:r>
               <a:rPr lang="en-US" dirty="0"/>
-              <a:t>This mental model comes from the operations guide and explains every behaviour they'll meet: why changes take a minute to appear, why nothing can be broken by browsing, and why every change is traceable. Repeat the brochure line — it lands.</a:t>
+              <a:t>This mental model comes from the operations guide and explains every behaviour they'll meet: why changes take a minute to appear, why nothing can be broken by browsing, and why every change is traceable. Repeat the brochure line. It lands.</a:t>
             </a:r>
             <a:endParaRPr lang="en-US" dirty="0"/>
           </a:p>
@@ -1041,7 +1041,7 @@
           <a:p>
             <a:r>
               <a:rPr lang="en-US" dirty="0"/>
-              <a:t>Reassure the room: a Claude session is a conversation, not a control panel. Nothing they type goes live by itself — there's a deliberate step (commit, then the automatic republish) between conversation and the public site.</a:t>
+              <a:t>Reassure the room: a Claude session is a conversation, not a control panel. Nothing they type goes live by itself. There is a deliberate step (commit, then the automatic republish) between conversation and the public site.</a:t>
             </a:r>
             <a:endParaRPr lang="en-US" dirty="0"/>
           </a:p>
@@ -1129,7 +1129,7 @@
           <a:p>
             <a:r>
               <a:rPr lang="en-US" dirty="0"/>
-              <a:t>These four examples come straight from the operations guide and cover 90% of day-to-day requests. Encourage people to include the page name and exact wording they want — precision in, precision out.</a:t>
+              <a:t>These four examples come straight from the operations guide and cover 90% of day-to-day requests. Encourage people to include the page name and exact wording they want. Precision in, precision out.</a:t>
             </a:r>
             <a:endParaRPr lang="en-US" dirty="0"/>
           </a:p>
@@ -1217,7 +1217,7 @@
           <a:p>
             <a:r>
               <a:rPr lang="en-US" dirty="0"/>
-              <a:t>“Commit and push” is the one phrase worth memorising. Explain the audit trail: this is why the repository approach is safer than editing a live site — every version of every page, forever.</a:t>
+              <a:t>“Commit and push” is the one phrase worth memorising. Explain the audit trail: this is why the repository approach is safer than editing a live site. Every version of every page, forever.</a:t>
             </a:r>
             <a:endParaRPr lang="en-US" dirty="0"/>
           </a:p>
@@ -1305,7 +1305,7 @@
           <a:p>
             <a:r>
               <a:rPr lang="en-US" dirty="0"/>
-              <a:t>Set the expectation of a few minutes' delay — it prevents the “it didn't work” moment when a change hasn't propagated yet. The verification habit (always look at the live page) catches misunderstandings early.</a:t>
+              <a:t>Set the expectation of a few minutes' delay. It prevents the “it didn't work” moment when a change hasn't propagated yet. The verification habit (always look at the live page) catches misunderstandings early.</a:t>
             </a:r>
             <a:endParaRPr lang="en-US" dirty="0"/>
           </a:p>
@@ -1393,7 +1393,7 @@
           <a:p>
             <a:r>
               <a:rPr lang="en-US" dirty="0"/>
-              <a:t>This is the guide's own recipe. The point to land: gather the five ingredients before starting, then it's one message and under an hour — most of which is Claude working, not you.</a:t>
+              <a:t>This is the guide's own recipe. The point to land: gather the five ingredients before starting, then it's one message and under an hour, most of which is Claude working, not you.</a:t>
             </a:r>
             <a:endParaRPr lang="en-US" dirty="0"/>
           </a:p>
@@ -1481,7 +1481,7 @@
           <a:p>
             <a:r>
               <a:rPr lang="en-US" dirty="0"/>
-              <a:t>One slide of gentle demystification. The takeaway isn't the file names — it's that the site is structured data plus a design system, which is why plain-English requests work so reliably.</a:t>
+              <a:t>One slide of gentle demystification. The takeaway isn't the file names. It's that the site is structured data plus a design system, which is why plain-English requests work so reliably.</a:t>
             </a:r>
             <a:endParaRPr lang="en-US" dirty="0"/>
           </a:p>
@@ -1956,7 +1956,7 @@
                 <a:ea typeface="Work Sans" pitchFamily="34" charset="-122"/>
                 <a:cs typeface="Work Sans" pitchFamily="34" charset="-120"/>
               </a:rPr>
-              <a:t>SATIS GROUP — BACKEND WEBINAR SERIES</a:t>
+              <a:t>SATIS GROUP · BACKEND WEBINAR SERIES</a:t>
             </a:r>
             <a:endParaRPr lang="en-US" sz="950" dirty="0"/>
           </a:p>
@@ -2115,7 +2115,7 @@
                 <a:ea typeface="Work Sans" pitchFamily="34" charset="-122"/>
                 <a:cs typeface="Work Sans" pitchFamily="34" charset="-120"/>
               </a:rPr>
-              <a:t>How anyone on the team changes pages, photos and copy — by describing the change in plain English.</a:t>
+              <a:t>How anyone on the team changes pages, photos and copy, just by describing the change in plain English.</a:t>
             </a:r>
             <a:endParaRPr lang="en-US" sz="1200" dirty="0"/>
           </a:p>
@@ -2358,7 +2358,7 @@
                 <a:ea typeface="Work Sans" pitchFamily="34" charset="-122"/>
                 <a:cs typeface="Work Sans" pitchFamily="34" charset="-120"/>
               </a:rPr>
-              <a:t>SATIS GROUP — EDITING THE WEBSITE WITH CLAUDE</a:t>
+              <a:t>SATIS GROUP · EDITING THE WEBSITE WITH CLAUDE</a:t>
             </a:r>
             <a:endParaRPr lang="en-US" sz="700" dirty="0"/>
           </a:p>
@@ -2478,7 +2478,7 @@
                 <a:ea typeface="Work Sans" pitchFamily="34" charset="-122"/>
                 <a:cs typeface="Work Sans" pitchFamily="34" charset="-120"/>
               </a:rPr>
-              <a:t>The repository carries a catalogue of professional “skills” Claude loads to work to a set standard. You never install anything — ask for the outcome and the right playbook loads:</a:t>
+              <a:t>The repository carries a catalogue of professional “skills” Claude loads to work to a set standard. You never install anything; ask for the outcome and the right playbook loads:</a:t>
             </a:r>
             <a:endParaRPr lang="en-US" sz="1150" dirty="0"/>
           </a:p>
@@ -3228,7 +3228,7 @@
                 <a:ea typeface="Work Sans" pitchFamily="34" charset="-122"/>
                 <a:cs typeface="Work Sans" pitchFamily="34" charset="-120"/>
               </a:rPr>
-              <a:t>Site-wide sweeps — how the current standards were set.</a:t>
+              <a:t>Site-wide sweeps: how the current standards were set.</a:t>
             </a:r>
             <a:endParaRPr lang="en-US" sz="1100" dirty="0"/>
           </a:p>
@@ -3439,7 +3439,7 @@
                 <a:ea typeface="Work Sans" pitchFamily="34" charset="-122"/>
                 <a:cs typeface="Work Sans" pitchFamily="34" charset="-120"/>
               </a:rPr>
-              <a:t>SATIS GROUP — EDITING THE WEBSITE WITH CLAUDE</a:t>
+              <a:t>SATIS GROUP · EDITING THE WEBSITE WITH CLAUDE</a:t>
             </a:r>
             <a:endParaRPr lang="en-US" sz="700" dirty="0"/>
           </a:p>
@@ -3562,7 +3562,7 @@
                 <a:ea typeface="Work Sans" pitchFamily="34" charset="-122"/>
                 <a:cs typeface="Work Sans" pitchFamily="34" charset="-120"/>
               </a:rPr>
-              <a:t>Every change is a dated snapshot that can be rolled back. Claude explains what it changed before it commits, and the live site only ever reprints from the master copy. If anything ever looks wrong: ask Claude to undo the last change — that is a one-sentence request too.</a:t>
+              <a:t>Every change is a dated snapshot that can be rolled back. Claude explains what it changed before it commits, and the live site only ever reprints from the master copy. If anything ever looks wrong: ask Claude to undo the last change. That is a one-sentence request too.</a:t>
             </a:r>
             <a:endParaRPr lang="en-US" sz="1250" dirty="0"/>
           </a:p>
@@ -3773,7 +3773,7 @@
                 <a:ea typeface="Work Sans" pitchFamily="34" charset="-122"/>
                 <a:cs typeface="Work Sans" pitchFamily="34" charset="-120"/>
               </a:rPr>
-              <a:t>SATIS GROUP — EDITING THE WEBSITE WITH CLAUDE</a:t>
+              <a:t>SATIS GROUP · EDITING THE WEBSITE WITH CLAUDE</a:t>
             </a:r>
             <a:endParaRPr lang="en-US" sz="700" dirty="0"/>
           </a:p>
@@ -3897,7 +3897,7 @@
                 <a:ea typeface="Work Sans" pitchFamily="34" charset="-122"/>
                 <a:cs typeface="Work Sans" pitchFamily="34" charset="-120"/>
               </a:rPr>
-              <a:t>The live site reprints from a master copy — Claude is how you edit the master.</a:t>
+              <a:t>The live site reprints from a master copy; Claude is how you edit the master.</a:t>
             </a:r>
             <a:endParaRPr lang="en-US" sz="1250" dirty="0"/>
           </a:p>
@@ -4123,7 +4123,7 @@
                 <a:ea typeface="Work Sans" pitchFamily="34" charset="-122"/>
                 <a:cs typeface="Work Sans" pitchFamily="34" charset="-120"/>
               </a:rPr>
-              <a:t>Stuck mid-session? Ask Claude itself — “explain what just happened” works.</a:t>
+              <a:t>Stuck mid-session? Ask Claude itself: “explain what just happened” works.</a:t>
             </a:r>
             <a:endParaRPr lang="en-US" sz="1050" dirty="0"/>
           </a:p>
@@ -4428,7 +4428,7 @@
                 <a:ea typeface="Work Sans" pitchFamily="34" charset="-122"/>
                 <a:cs typeface="Work Sans" pitchFamily="34" charset="-120"/>
               </a:rPr>
-              <a:t>SATIS GROUP — EDITING THE WEBSITE WITH CLAUDE</a:t>
+              <a:t>SATIS GROUP · EDITING THE WEBSITE WITH CLAUDE</a:t>
             </a:r>
             <a:endParaRPr lang="en-US" sz="700" dirty="0"/>
           </a:p>
@@ -4668,7 +4668,7 @@
                 <a:ea typeface="Work Sans" pitchFamily="34" charset="-122"/>
                 <a:cs typeface="Work Sans" pitchFamily="34" charset="-120"/>
               </a:rPr>
-              <a:t>The live site is a printed brochure — you change the master copy, not the print.</a:t>
+              <a:t>The live site is a printed brochure: you change the master copy, not the print.</a:t>
             </a:r>
             <a:endParaRPr lang="en-US" sz="950" dirty="0"/>
           </a:p>
@@ -5028,7 +5028,7 @@
                 <a:ea typeface="Work Sans" pitchFamily="34" charset="-122"/>
                 <a:cs typeface="Work Sans" pitchFamily="34" charset="-120"/>
               </a:rPr>
-              <a:t>“…then commit and push the change” — and what happens next.</a:t>
+              <a:t>“…then commit and push the change”, and what happens next.</a:t>
             </a:r>
             <a:endParaRPr lang="en-US" sz="950" dirty="0"/>
           </a:p>
@@ -5472,7 +5472,7 @@
                 <a:ea typeface="Work Sans" pitchFamily="34" charset="-122"/>
                 <a:cs typeface="Work Sans" pitchFamily="34" charset="-120"/>
               </a:rPr>
-              <a:t>SATIS GROUP — EDITING THE WEBSITE WITH CLAUDE</a:t>
+              <a:t>SATIS GROUP · EDITING THE WEBSITE WITH CLAUDE</a:t>
             </a:r>
             <a:endParaRPr lang="en-US" sz="700" dirty="0"/>
           </a:p>
@@ -5592,7 +5592,7 @@
                 <a:ea typeface="Work Sans" pitchFamily="34" charset="-122"/>
                 <a:cs typeface="Work Sans" pitchFamily="34" charset="-120"/>
               </a:rPr>
-              <a:t>You cannot scribble on a printed brochure — you change the master copy and print a new one. The master copy of this website lives in a shared, version-tracked folder called the repository, and the live site reprints itself automatically whenever the master changes.</a:t>
+              <a:t>You cannot scribble on a printed brochure: you change the master copy and print a new one. The master copy of this website lives in a shared, version-tracked folder called the repository, and the live site reprints itself automatically whenever the master changes.</a:t>
             </a:r>
             <a:endParaRPr lang="en-US" sz="1150" dirty="0"/>
           </a:p>
@@ -6134,7 +6134,7 @@
                 <a:ea typeface="Work Sans" pitchFamily="34" charset="-122"/>
                 <a:cs typeface="Work Sans" pitchFamily="34" charset="-120"/>
               </a:rPr>
-              <a:t>nothing changes until it reaches the master copy, and every change to the master is recorded — so nothing is ever lost.</a:t>
+              <a:t>nothing changes until it reaches the master copy, and every change to the master is recorded, so nothing is ever lost.</a:t>
             </a:r>
             <a:endParaRPr lang="en-US" sz="1150" dirty="0"/>
           </a:p>
@@ -6338,7 +6338,7 @@
                 <a:ea typeface="Work Sans" pitchFamily="34" charset="-122"/>
                 <a:cs typeface="Work Sans" pitchFamily="34" charset="-120"/>
               </a:rPr>
-              <a:t>SATIS GROUP — EDITING THE WEBSITE WITH CLAUDE</a:t>
+              <a:t>SATIS GROUP · EDITING THE WEBSITE WITH CLAUDE</a:t>
             </a:r>
             <a:endParaRPr lang="en-US" sz="700" dirty="0"/>
           </a:p>
@@ -6458,7 +6458,7 @@
                 <a:ea typeface="Work Sans" pitchFamily="34" charset="-122"/>
                 <a:cs typeface="Work Sans" pitchFamily="34" charset="-120"/>
               </a:rPr>
-              <a:t>Claude Code is Claude working directly on the website's repository. You reach it from a web browser — nothing to install.</a:t>
+              <a:t>Claude Code is Claude working directly on the website's repository. You reach it from a web browser; there is nothing to install.</a:t>
             </a:r>
             <a:endParaRPr lang="en-US" sz="1150" dirty="0"/>
           </a:p>
@@ -6546,7 +6546,7 @@
                 <a:ea typeface="Work Sans" pitchFamily="34" charset="-122"/>
                 <a:cs typeface="Work Sans" pitchFamily="34" charset="-120"/>
               </a:rPr>
-              <a:t>The written version of this walkthrough lives at /admin/guide — chapter “Making changes with Claude”.</a:t>
+              <a:t>The written version of this walkthrough lives at /admin/guide, chapter “Making changes with Claude”.</a:t>
             </a:r>
             <a:endParaRPr lang="en-US" sz="850" dirty="0"/>
           </a:p>
@@ -6686,7 +6686,7 @@
                 <a:ea typeface="Work Sans" pitchFamily="34" charset="-122"/>
                 <a:cs typeface="Work Sans" pitchFamily="34" charset="-120"/>
               </a:rPr>
-              <a:t>Sign in with your work Claude account. The development team sets up your access the first time — ask once, use forever.</a:t>
+              <a:t>Sign in with your work Claude account. The development team sets up your access the first time; ask once, use forever.</a:t>
             </a:r>
             <a:endParaRPr lang="en-US" sz="1050" dirty="0"/>
           </a:p>
@@ -7295,7 +7295,7 @@
                 <a:ea typeface="Work Sans" pitchFamily="34" charset="-122"/>
                 <a:cs typeface="Work Sans" pitchFamily="34" charset="-120"/>
               </a:rPr>
-              <a:t>SATIS GROUP — EDITING THE WEBSITE WITH CLAUDE</a:t>
+              <a:t>SATIS GROUP · EDITING THE WEBSITE WITH CLAUDE</a:t>
             </a:r>
             <a:endParaRPr lang="en-US" sz="700" dirty="0"/>
           </a:p>
@@ -7373,7 +7373,7 @@
                 <a:ea typeface="Work Sans" pitchFamily="34" charset="-122"/>
                 <a:cs typeface="Work Sans" pitchFamily="34" charset="-120"/>
               </a:rPr>
-              <a:t>Proven requests — copy these word for word.</a:t>
+              <a:t>Proven requests, copy these word for word.</a:t>
             </a:r>
             <a:endParaRPr lang="en-US" sz="2500" dirty="0"/>
           </a:p>
@@ -7501,7 +7501,7 @@
                 <a:ea typeface="Work Sans" pitchFamily="34" charset="-122"/>
                 <a:cs typeface="Work Sans" pitchFamily="34" charset="-120"/>
               </a:rPr>
-              <a:t>Content edits — statuses, copy, dates, figures.</a:t>
+              <a:t>Content edits: statuses, copy, dates, figures.</a:t>
             </a:r>
             <a:endParaRPr lang="en-US" sz="1150" dirty="0"/>
           </a:p>
@@ -7587,7 +7587,7 @@
                 <a:ea typeface="Work Sans" pitchFamily="34" charset="-122"/>
                 <a:cs typeface="Work Sans" pitchFamily="34" charset="-120"/>
               </a:rPr>
-              <a:t>Photography — attach the image to your message.</a:t>
+              <a:t>Photography: attach the image to your message.</a:t>
             </a:r>
             <a:endParaRPr lang="en-US" sz="1150" dirty="0"/>
           </a:p>
@@ -7673,7 +7673,7 @@
                 <a:ea typeface="Work Sans" pitchFamily="34" charset="-122"/>
                 <a:cs typeface="Work Sans" pitchFamily="34" charset="-120"/>
               </a:rPr>
-              <a:t>Additions — awards, team members, accolades.</a:t>
+              <a:t>Additions: awards, team members, accolades.</a:t>
             </a:r>
             <a:endParaRPr lang="en-US" sz="1150" dirty="0"/>
           </a:p>
@@ -7759,7 +7759,7 @@
                 <a:ea typeface="Work Sans" pitchFamily="34" charset="-122"/>
                 <a:cs typeface="Work Sans" pitchFamily="34" charset="-120"/>
               </a:rPr>
-              <a:t>Small fixes — describe what's wrong and what right looks like.</a:t>
+              <a:t>Small fixes: describe what's wrong and what right looks like.</a:t>
             </a:r>
             <a:endParaRPr lang="en-US" sz="1150" dirty="0"/>
           </a:p>
@@ -7963,7 +7963,7 @@
                 <a:ea typeface="Work Sans" pitchFamily="34" charset="-122"/>
                 <a:cs typeface="Work Sans" pitchFamily="34" charset="-120"/>
               </a:rPr>
-              <a:t>SATIS GROUP — EDITING THE WEBSITE WITH CLAUDE</a:t>
+              <a:t>SATIS GROUP · EDITING THE WEBSITE WITH CLAUDE</a:t>
             </a:r>
             <a:endParaRPr lang="en-US" sz="700" dirty="0"/>
           </a:p>
@@ -8083,7 +8083,7 @@
                 <a:ea typeface="Work Sans" pitchFamily="34" charset="-122"/>
                 <a:cs typeface="Work Sans" pitchFamily="34" charset="-120"/>
               </a:rPr>
-              <a:t>A commit is a saved, dated snapshot of the master copy with a note of what changed and why. Committing and pushing is what sends your change to the master — and the master is what the live site reprints from.</a:t>
+              <a:t>A commit is a saved, dated snapshot of the master copy with a note of what changed and why. Committing and pushing is what sends your change to the master, and the master is what the live site reprints from.</a:t>
             </a:r>
             <a:endParaRPr lang="en-US" sz="1150" dirty="0"/>
           </a:p>
@@ -8287,7 +8287,7 @@
                 <a:ea typeface="Work Sans" pitchFamily="34" charset="-122"/>
                 <a:cs typeface="Work Sans" pitchFamily="34" charset="-120"/>
               </a:rPr>
-              <a:t>Without the magic words the edit stays in the session — reviewed but not sent. With them, Claude commits, pushes, and tells you when it is done.</a:t>
+              <a:t>Without the magic words the edit stays in the session: reviewed but not sent. With them, Claude commits, pushes, and tells you when it is done.</a:t>
             </a:r>
             <a:endParaRPr lang="en-US" sz="1100" dirty="0"/>
           </a:p>
@@ -8346,7 +8346,7 @@
                 <a:ea typeface="Work Sans" pitchFamily="34" charset="-122"/>
                 <a:cs typeface="Work Sans" pitchFamily="34" charset="-120"/>
               </a:rPr>
-              <a:t>Every change is dated, described and attributed — and any mistake can be rolled back to the snapshot before it. Ask Claude “what changed this month?” and it can tell you.</a:t>
+              <a:t>Every change is dated, described and attributed, and any mistake can be rolled back to the snapshot before it. Ask Claude “what changed this month?” and it can tell you.</a:t>
             </a:r>
             <a:endParaRPr lang="en-US" sz="1150" dirty="0"/>
           </a:p>
@@ -8550,7 +8550,7 @@
                 <a:ea typeface="Work Sans" pitchFamily="34" charset="-122"/>
                 <a:cs typeface="Work Sans" pitchFamily="34" charset="-120"/>
               </a:rPr>
-              <a:t>SATIS GROUP — EDITING THE WEBSITE WITH CLAUDE</a:t>
+              <a:t>SATIS GROUP · EDITING THE WEBSITE WITH CLAUDE</a:t>
             </a:r>
             <a:endParaRPr lang="en-US" sz="700" dirty="0"/>
           </a:p>
@@ -8628,7 +8628,7 @@
                 <a:ea typeface="Work Sans" pitchFamily="34" charset="-122"/>
                 <a:cs typeface="Work Sans" pitchFamily="34" charset="-120"/>
               </a:rPr>
-              <a:t>What happens next — and how to check.</a:t>
+              <a:t>What happens next, and how to check.</a:t>
             </a:r>
             <a:endParaRPr lang="en-US" sz="2500" dirty="0"/>
           </a:p>
@@ -8768,7 +8768,7 @@
                 <a:ea typeface="Work Sans" pitchFamily="34" charset="-122"/>
                 <a:cs typeface="Work Sans" pitchFamily="34" charset="-120"/>
               </a:rPr>
-              <a:t>It tells you what it changed and that the change is pushed. If the team reviews changes first, it opens a pull request — a change waiting for approval — instead.</a:t>
+              <a:t>It tells you what it changed and that the change is pushed. If the team reviews changes first, it opens a pull request instead (a change waiting for approval).</a:t>
             </a:r>
             <a:endParaRPr lang="en-US" sz="1050" dirty="0"/>
           </a:p>
@@ -9048,7 +9048,7 @@
                 <a:ea typeface="Work Sans" pitchFamily="34" charset="-122"/>
                 <a:cs typeface="Work Sans" pitchFamily="34" charset="-120"/>
               </a:rPr>
-              <a:t>Open the page and check your change is showing. Not there after ten minutes? Ask in the same Claude session: “Was the commit pushed, and did the deployment succeed?” — Claude can check both.</a:t>
+              <a:t>Open the page and check your change is showing. Not there after ten minutes? Ask in the same Claude session: “Was the commit pushed, and did the deployment succeed?” Claude can check both.</a:t>
             </a:r>
             <a:endParaRPr lang="en-US" sz="1050" dirty="0"/>
           </a:p>
@@ -9382,7 +9382,7 @@
                 <a:ea typeface="Work Sans" pitchFamily="34" charset="-122"/>
                 <a:cs typeface="Work Sans" pitchFamily="34" charset="-120"/>
               </a:rPr>
-              <a:t>SATIS GROUP — EDITING THE WEBSITE WITH CLAUDE</a:t>
+              <a:t>SATIS GROUP · EDITING THE WEBSITE WITH CLAUDE</a:t>
             </a:r>
             <a:endParaRPr lang="en-US" sz="700" dirty="0"/>
           </a:p>
@@ -9460,7 +9460,7 @@
                 <a:ea typeface="Work Sans" pitchFamily="34" charset="-122"/>
                 <a:cs typeface="Work Sans" pitchFamily="34" charset="-120"/>
               </a:rPr>
-              <a:t>Adding a whole new development — one request.</a:t>
+              <a:t>Adding a whole new development, in one request.</a:t>
             </a:r>
             <a:endParaRPr lang="en-US" sz="2500" dirty="0"/>
           </a:p>
@@ -9502,7 +9502,7 @@
                 <a:ea typeface="Work Sans" pitchFamily="34" charset="-122"/>
                 <a:cs typeface="Work Sans" pitchFamily="34" charset="-120"/>
               </a:rPr>
-              <a:t>A new development touches the portfolio grid, its own property page, the map and the investor platform. Claude follows a set checklist — you just supply the ingredients:</a:t>
+              <a:t>A new development touches the portfolio grid, its own property page, the map and the investor platform. Claude follows a set checklist; you just supply the ingredients:</a:t>
             </a:r>
             <a:endParaRPr lang="en-US" sz="1150" dirty="0"/>
           </a:p>
@@ -10536,7 +10536,7 @@
                 <a:ea typeface="Work Sans" pitchFamily="34" charset="-122"/>
                 <a:cs typeface="Work Sans" pitchFamily="34" charset="-120"/>
               </a:rPr>
-              <a:t>SATIS GROUP — EDITING THE WEBSITE WITH CLAUDE</a:t>
+              <a:t>SATIS GROUP · EDITING THE WEBSITE WITH CLAUDE</a:t>
             </a:r>
             <a:endParaRPr lang="en-US" sz="700" dirty="0"/>
           </a:p>
@@ -10659,7 +10659,7 @@
                 <a:ea typeface="Work Sans" pitchFamily="34" charset="-122"/>
                 <a:cs typeface="Work Sans" pitchFamily="34" charset="-120"/>
               </a:rPr>
-              <a:t>The public website is data-driven: every page is generated from structured files in the repository. You never edit a page's design — you change the data and the design applies itself.
+              <a:t>The public website is data-driven: every page is generated from structured files in the repository. You never edit a page's design; you change the data and the design applies itself.
 </a:t>
             </a:r>
             <a:pPr indent="0" marL="0">
@@ -10701,7 +10701,7 @@
                 <a:ea typeface="Work Sans" pitchFamily="34" charset="-122"/>
                 <a:cs typeface="Work Sans" pitchFamily="34" charset="-120"/>
               </a:rPr>
-              <a:t>Portfolio cards — lib/portfolio-data.ts
+              <a:t>Portfolio cards: lib/portfolio-data.ts
 </a:t>
             </a:r>
             <a:pPr indent="0" marL="0">
@@ -10722,7 +10722,7 @@
                 <a:ea typeface="Work Sans" pitchFamily="34" charset="-122"/>
                 <a:cs typeface="Work Sans" pitchFamily="34" charset="-120"/>
               </a:rPr>
-              <a:t>Property pages — lib/property-pages.ts
+              <a:t>Property pages: lib/property-pages.ts
 </a:t>
             </a:r>
             <a:pPr indent="0" marL="0">
@@ -10743,7 +10743,7 @@
                 <a:ea typeface="Work Sans" pitchFamily="34" charset="-122"/>
                 <a:cs typeface="Work Sans" pitchFamily="34" charset="-120"/>
               </a:rPr>
-              <a:t>Photography — public/images/
+              <a:t>Photography: public/images/
 </a:t>
             </a:r>
             <a:pPr indent="0" marL="0">
@@ -10764,7 +10764,7 @@
                 <a:ea typeface="Work Sans" pitchFamily="34" charset="-122"/>
                 <a:cs typeface="Work Sans" pitchFamily="34" charset="-120"/>
               </a:rPr>
-              <a:t>News stories — content/newsletters/
+              <a:t>News stories: content/newsletters/
 </a:t>
             </a:r>
             <a:pPr indent="0" marL="0">
@@ -10785,7 +10785,7 @@
                 <a:ea typeface="Work Sans" pitchFamily="34" charset="-122"/>
                 <a:cs typeface="Work Sans" pitchFamily="34" charset="-120"/>
               </a:rPr>
-              <a:t>Investor data — content/investors/
+              <a:t>Investor data: content/investors/
 </a:t>
             </a:r>
             <a:endParaRPr lang="en-US" sz="1100" dirty="0"/>
@@ -10874,7 +10874,7 @@
                 <a:ea typeface="Work Sans" pitchFamily="34" charset="-122"/>
                 <a:cs typeface="Work Sans" pitchFamily="34" charset="-120"/>
               </a:rPr>
-              <a:t>Every card on the portfolio grid is generated from a data file — no page is edited by hand.</a:t>
+              <a:t>Every card on the portfolio grid is generated from a data file. No page is edited by hand.</a:t>
             </a:r>
             <a:endParaRPr lang="en-US" sz="850" dirty="0"/>
           </a:p>

</xml_diff>